<commit_message>
Memoria de practicas anadida
</commit_message>
<xml_diff>
--- a/PRESENTATION EFFICACY TREATMENT - DAVID VALCÁRCEL.pptx
+++ b/PRESENTATION EFFICACY TREATMENT - DAVID VALCÁRCEL.pptx
@@ -5,7 +5,7 @@
     <p:sldMasterId id="2147483713" r:id="rId1"/>
   </p:sldMasterIdLst>
   <p:notesMasterIdLst>
-    <p:notesMasterId r:id="rId25"/>
+    <p:notesMasterId r:id="rId26"/>
   </p:notesMasterIdLst>
   <p:sldIdLst>
     <p:sldId id="256" r:id="rId2"/>
@@ -19,18 +19,19 @@
     <p:sldId id="271" r:id="rId10"/>
     <p:sldId id="272" r:id="rId11"/>
     <p:sldId id="261" r:id="rId12"/>
-    <p:sldId id="274" r:id="rId13"/>
-    <p:sldId id="275" r:id="rId14"/>
-    <p:sldId id="276" r:id="rId15"/>
-    <p:sldId id="279" r:id="rId16"/>
-    <p:sldId id="281" r:id="rId17"/>
-    <p:sldId id="282" r:id="rId18"/>
-    <p:sldId id="283" r:id="rId19"/>
-    <p:sldId id="273" r:id="rId20"/>
-    <p:sldId id="284" r:id="rId21"/>
-    <p:sldId id="285" r:id="rId22"/>
-    <p:sldId id="264" r:id="rId23"/>
-    <p:sldId id="265" r:id="rId24"/>
+    <p:sldId id="286" r:id="rId13"/>
+    <p:sldId id="274" r:id="rId14"/>
+    <p:sldId id="275" r:id="rId15"/>
+    <p:sldId id="276" r:id="rId16"/>
+    <p:sldId id="279" r:id="rId17"/>
+    <p:sldId id="281" r:id="rId18"/>
+    <p:sldId id="282" r:id="rId19"/>
+    <p:sldId id="283" r:id="rId20"/>
+    <p:sldId id="273" r:id="rId21"/>
+    <p:sldId id="284" r:id="rId22"/>
+    <p:sldId id="285" r:id="rId23"/>
+    <p:sldId id="264" r:id="rId24"/>
+    <p:sldId id="265" r:id="rId25"/>
   </p:sldIdLst>
   <p:sldSz cx="12192000" cy="6858000"/>
   <p:notesSz cx="6858000" cy="9144000"/>
@@ -2953,7 +2954,7 @@
           <a:p>
             <a:fld id="{82A9F2C7-6AB5-4B2D-A231-F8CD7648FE5F}" type="datetimeFigureOut">
               <a:rPr lang="en-GB" smtClean="0"/>
-              <a:t>29/07/2025</a:t>
+              <a:t>11/09/2025</a:t>
             </a:fld>
             <a:endParaRPr lang="en-GB"/>
           </a:p>
@@ -3286,7 +3287,7 @@
           <a:p>
             <a:fld id="{87F0930D-D2EC-476A-9833-118846D19211}" type="slidenum">
               <a:rPr lang="en-GB" smtClean="0"/>
-              <a:t>14</a:t>
+              <a:t>15</a:t>
             </a:fld>
             <a:endParaRPr lang="en-GB"/>
           </a:p>
@@ -3370,7 +3371,7 @@
           <a:p>
             <a:fld id="{87F0930D-D2EC-476A-9833-118846D19211}" type="slidenum">
               <a:rPr lang="en-GB" smtClean="0"/>
-              <a:t>19</a:t>
+              <a:t>20</a:t>
             </a:fld>
             <a:endParaRPr lang="en-GB"/>
           </a:p>
@@ -4111,7 +4112,7 @@
           <a:p>
             <a:fld id="{6AF85D1D-B2D2-42D7-B1AD-D2C733C17524}" type="datetimeFigureOut">
               <a:rPr lang="es-ES" smtClean="0"/>
-              <a:t>29/07/2025</a:t>
+              <a:t>11/09/2025</a:t>
             </a:fld>
             <a:endParaRPr lang="es-ES"/>
           </a:p>
@@ -4362,7 +4363,7 @@
           <a:p>
             <a:fld id="{6AF85D1D-B2D2-42D7-B1AD-D2C733C17524}" type="datetimeFigureOut">
               <a:rPr lang="es-ES" smtClean="0"/>
-              <a:t>29/07/2025</a:t>
+              <a:t>11/09/2025</a:t>
             </a:fld>
             <a:endParaRPr lang="es-ES"/>
           </a:p>
@@ -4676,7 +4677,7 @@
           <a:p>
             <a:fld id="{6AF85D1D-B2D2-42D7-B1AD-D2C733C17524}" type="datetimeFigureOut">
               <a:rPr lang="es-ES" smtClean="0"/>
-              <a:t>29/07/2025</a:t>
+              <a:t>11/09/2025</a:t>
             </a:fld>
             <a:endParaRPr lang="es-ES"/>
           </a:p>
@@ -5017,7 +5018,7 @@
           <a:p>
             <a:fld id="{6AF85D1D-B2D2-42D7-B1AD-D2C733C17524}" type="datetimeFigureOut">
               <a:rPr lang="es-ES" smtClean="0"/>
-              <a:t>29/07/2025</a:t>
+              <a:t>11/09/2025</a:t>
             </a:fld>
             <a:endParaRPr lang="es-ES"/>
           </a:p>
@@ -5331,7 +5332,7 @@
           <a:p>
             <a:fld id="{6AF85D1D-B2D2-42D7-B1AD-D2C733C17524}" type="datetimeFigureOut">
               <a:rPr lang="es-ES" smtClean="0"/>
-              <a:t>29/07/2025</a:t>
+              <a:t>11/09/2025</a:t>
             </a:fld>
             <a:endParaRPr lang="es-ES"/>
           </a:p>
@@ -5724,7 +5725,7 @@
           <a:p>
             <a:fld id="{6AF85D1D-B2D2-42D7-B1AD-D2C733C17524}" type="datetimeFigureOut">
               <a:rPr lang="es-ES" smtClean="0"/>
-              <a:t>29/07/2025</a:t>
+              <a:t>11/09/2025</a:t>
             </a:fld>
             <a:endParaRPr lang="es-ES"/>
           </a:p>
@@ -5894,7 +5895,7 @@
           <a:p>
             <a:fld id="{6AF85D1D-B2D2-42D7-B1AD-D2C733C17524}" type="datetimeFigureOut">
               <a:rPr lang="es-ES" smtClean="0"/>
-              <a:t>29/07/2025</a:t>
+              <a:t>11/09/2025</a:t>
             </a:fld>
             <a:endParaRPr lang="es-ES"/>
           </a:p>
@@ -6074,7 +6075,7 @@
           <a:p>
             <a:fld id="{6AF85D1D-B2D2-42D7-B1AD-D2C733C17524}" type="datetimeFigureOut">
               <a:rPr lang="es-ES" smtClean="0"/>
-              <a:t>29/07/2025</a:t>
+              <a:t>11/09/2025</a:t>
             </a:fld>
             <a:endParaRPr lang="es-ES"/>
           </a:p>
@@ -6250,7 +6251,7 @@
           <a:p>
             <a:fld id="{6AF85D1D-B2D2-42D7-B1AD-D2C733C17524}" type="datetimeFigureOut">
               <a:rPr lang="es-ES" smtClean="0"/>
-              <a:t>29/07/2025</a:t>
+              <a:t>11/09/2025</a:t>
             </a:fld>
             <a:endParaRPr lang="es-ES"/>
           </a:p>
@@ -6497,7 +6498,7 @@
           <a:p>
             <a:fld id="{6AF85D1D-B2D2-42D7-B1AD-D2C733C17524}" type="datetimeFigureOut">
               <a:rPr lang="es-ES" smtClean="0"/>
-              <a:t>29/07/2025</a:t>
+              <a:t>11/09/2025</a:t>
             </a:fld>
             <a:endParaRPr lang="es-ES"/>
           </a:p>
@@ -6729,7 +6730,7 @@
           <a:p>
             <a:fld id="{6AF85D1D-B2D2-42D7-B1AD-D2C733C17524}" type="datetimeFigureOut">
               <a:rPr lang="es-ES" smtClean="0"/>
-              <a:t>29/07/2025</a:t>
+              <a:t>11/09/2025</a:t>
             </a:fld>
             <a:endParaRPr lang="es-ES"/>
           </a:p>
@@ -7103,7 +7104,7 @@
           <a:p>
             <a:fld id="{6AF85D1D-B2D2-42D7-B1AD-D2C733C17524}" type="datetimeFigureOut">
               <a:rPr lang="es-ES" smtClean="0"/>
-              <a:t>29/07/2025</a:t>
+              <a:t>11/09/2025</a:t>
             </a:fld>
             <a:endParaRPr lang="es-ES"/>
           </a:p>
@@ -7226,7 +7227,7 @@
           <a:p>
             <a:fld id="{6AF85D1D-B2D2-42D7-B1AD-D2C733C17524}" type="datetimeFigureOut">
               <a:rPr lang="es-ES" smtClean="0"/>
-              <a:t>29/07/2025</a:t>
+              <a:t>11/09/2025</a:t>
             </a:fld>
             <a:endParaRPr lang="es-ES"/>
           </a:p>
@@ -7321,7 +7322,7 @@
           <a:p>
             <a:fld id="{6AF85D1D-B2D2-42D7-B1AD-D2C733C17524}" type="datetimeFigureOut">
               <a:rPr lang="es-ES" smtClean="0"/>
-              <a:t>29/07/2025</a:t>
+              <a:t>11/09/2025</a:t>
             </a:fld>
             <a:endParaRPr lang="es-ES"/>
           </a:p>
@@ -7576,7 +7577,7 @@
           <a:p>
             <a:fld id="{6AF85D1D-B2D2-42D7-B1AD-D2C733C17524}" type="datetimeFigureOut">
               <a:rPr lang="es-ES" smtClean="0"/>
-              <a:t>29/07/2025</a:t>
+              <a:t>11/09/2025</a:t>
             </a:fld>
             <a:endParaRPr lang="es-ES"/>
           </a:p>
@@ -7839,7 +7840,7 @@
           <a:p>
             <a:fld id="{6AF85D1D-B2D2-42D7-B1AD-D2C733C17524}" type="datetimeFigureOut">
               <a:rPr lang="es-ES" smtClean="0"/>
-              <a:t>29/07/2025</a:t>
+              <a:t>11/09/2025</a:t>
             </a:fld>
             <a:endParaRPr lang="es-ES"/>
           </a:p>
@@ -8582,7 +8583,7 @@
           <a:p>
             <a:fld id="{6AF85D1D-B2D2-42D7-B1AD-D2C733C17524}" type="datetimeFigureOut">
               <a:rPr lang="es-ES" smtClean="0"/>
-              <a:t>29/07/2025</a:t>
+              <a:t>11/09/2025</a:t>
             </a:fld>
             <a:endParaRPr lang="es-ES"/>
           </a:p>
@@ -9788,6 +9789,175 @@
   <p:cSld>
     <p:spTree>
       <p:nvGrpSpPr>
+        <p:cNvPr id="1" name="">
+          <a:extLst>
+            <a:ext uri="{FF2B5EF4-FFF2-40B4-BE49-F238E27FC236}">
+              <a16:creationId xmlns:a16="http://schemas.microsoft.com/office/drawing/2014/main" id="{94AE4D8C-4A23-CDF3-AC98-9C859681E68D}"/>
+            </a:ext>
+          </a:extLst>
+        </p:cNvPr>
+        <p:cNvGrpSpPr/>
+        <p:nvPr/>
+      </p:nvGrpSpPr>
+      <p:grpSpPr>
+        <a:xfrm>
+          <a:off x="0" y="0"/>
+          <a:ext cx="0" cy="0"/>
+          <a:chOff x="0" y="0"/>
+          <a:chExt cx="0" cy="0"/>
+        </a:xfrm>
+      </p:grpSpPr>
+      <p:sp>
+        <p:nvSpPr>
+          <p:cNvPr id="2" name="Título 1">
+            <a:extLst>
+              <a:ext uri="{FF2B5EF4-FFF2-40B4-BE49-F238E27FC236}">
+                <a16:creationId xmlns:a16="http://schemas.microsoft.com/office/drawing/2014/main" id="{16896E77-9C38-3548-4773-447EF9CCC03B}"/>
+              </a:ext>
+            </a:extLst>
+          </p:cNvPr>
+          <p:cNvSpPr>
+            <a:spLocks noGrp="1"/>
+          </p:cNvSpPr>
+          <p:nvPr>
+            <p:ph type="title"/>
+          </p:nvPr>
+        </p:nvSpPr>
+        <p:spPr>
+          <a:xfrm>
+            <a:off x="677333" y="250372"/>
+            <a:ext cx="9119810" cy="1320800"/>
+          </a:xfrm>
+        </p:spPr>
+        <p:txBody>
+          <a:bodyPr>
+            <a:normAutofit/>
+          </a:bodyPr>
+          <a:lstStyle/>
+          <a:p>
+            <a:r>
+              <a:rPr lang="en-US" noProof="0" dirty="0"/>
+              <a:t>3. How persistent is each treatment and which of them is more persistent on time?</a:t>
+            </a:r>
+          </a:p>
+        </p:txBody>
+      </p:sp>
+      <p:pic>
+        <p:nvPicPr>
+          <p:cNvPr id="9" name="Marcador de contenido 8">
+            <a:extLst>
+              <a:ext uri="{FF2B5EF4-FFF2-40B4-BE49-F238E27FC236}">
+                <a16:creationId xmlns:a16="http://schemas.microsoft.com/office/drawing/2014/main" id="{DF4F89A4-3AB0-A366-70C7-0EF3E7CD6773}"/>
+              </a:ext>
+            </a:extLst>
+          </p:cNvPr>
+          <p:cNvPicPr>
+            <a:picLocks noGrp="1" noChangeAspect="1"/>
+          </p:cNvPicPr>
+          <p:nvPr>
+            <p:ph idx="1"/>
+          </p:nvPr>
+        </p:nvPicPr>
+        <p:blipFill>
+          <a:blip r:embed="rId2"/>
+          <a:stretch>
+            <a:fillRect/>
+          </a:stretch>
+        </p:blipFill>
+        <p:spPr>
+          <a:xfrm>
+            <a:off x="753533" y="1603827"/>
+            <a:ext cx="7748210" cy="5211645"/>
+          </a:xfrm>
+        </p:spPr>
+      </p:pic>
+      <p:sp>
+        <p:nvSpPr>
+          <p:cNvPr id="10" name="Rectángulo 9">
+            <a:extLst>
+              <a:ext uri="{FF2B5EF4-FFF2-40B4-BE49-F238E27FC236}">
+                <a16:creationId xmlns:a16="http://schemas.microsoft.com/office/drawing/2014/main" id="{C866F0B2-59D7-6309-FCB8-66E1F192EAEF}"/>
+              </a:ext>
+            </a:extLst>
+          </p:cNvPr>
+          <p:cNvSpPr/>
+          <p:nvPr/>
+        </p:nvSpPr>
+        <p:spPr>
+          <a:xfrm>
+            <a:off x="8654144" y="2438399"/>
+            <a:ext cx="3331028" cy="1545771"/>
+          </a:xfrm>
+          <a:prstGeom prst="rect">
+            <a:avLst/>
+          </a:prstGeom>
+        </p:spPr>
+        <p:style>
+          <a:lnRef idx="2">
+            <a:schemeClr val="accent1">
+              <a:shade val="15000"/>
+            </a:schemeClr>
+          </a:lnRef>
+          <a:fillRef idx="1">
+            <a:schemeClr val="accent1"/>
+          </a:fillRef>
+          <a:effectRef idx="0">
+            <a:schemeClr val="accent1"/>
+          </a:effectRef>
+          <a:fontRef idx="minor">
+            <a:schemeClr val="lt1"/>
+          </a:fontRef>
+        </p:style>
+        <p:txBody>
+          <a:bodyPr rtlCol="0" anchor="ctr"/>
+          <a:lstStyle/>
+          <a:p>
+            <a:pPr algn="ctr"/>
+            <a:r>
+              <a:rPr lang="en-US" noProof="0" dirty="0">
+                <a:solidFill>
+                  <a:schemeClr val="tx1"/>
+                </a:solidFill>
+              </a:rPr>
+              <a:t>Table showing </a:t>
+            </a:r>
+            <a:r>
+              <a:rPr lang="en-US" b="1" noProof="0" dirty="0">
+                <a:solidFill>
+                  <a:schemeClr val="tx1"/>
+                </a:solidFill>
+              </a:rPr>
+              <a:t>statistical grouping of treatments </a:t>
+            </a:r>
+            <a:r>
+              <a:rPr lang="en-US" noProof="0" dirty="0">
+                <a:solidFill>
+                  <a:schemeClr val="tx1"/>
+                </a:solidFill>
+              </a:rPr>
+              <a:t>using 4 LMM models and mean and standard deviation for each variable. </a:t>
+            </a:r>
+          </a:p>
+        </p:txBody>
+      </p:sp>
+    </p:spTree>
+    <p:extLst>
+      <p:ext uri="{BB962C8B-B14F-4D97-AF65-F5344CB8AC3E}">
+        <p14:creationId xmlns:p14="http://schemas.microsoft.com/office/powerpoint/2010/main" val="4065703289"/>
+      </p:ext>
+    </p:extLst>
+  </p:cSld>
+  <p:clrMapOvr>
+    <a:masterClrMapping/>
+  </p:clrMapOvr>
+</p:sld>
+</file>
+
+<file path=ppt/slides/slide13.xml><?xml version="1.0" encoding="utf-8"?>
+<p:sld xmlns:a="http://schemas.openxmlformats.org/drawingml/2006/main" xmlns:r="http://schemas.openxmlformats.org/officeDocument/2006/relationships" xmlns:p="http://schemas.openxmlformats.org/presentationml/2006/main">
+  <p:cSld>
+    <p:spTree>
+      <p:nvGrpSpPr>
         <p:cNvPr id="1" name=""/>
         <p:cNvGrpSpPr/>
         <p:nvPr/>
@@ -10076,7 +10246,7 @@
 </p:sld>
 </file>
 
-<file path=ppt/slides/slide13.xml><?xml version="1.0" encoding="utf-8"?>
+<file path=ppt/slides/slide14.xml><?xml version="1.0" encoding="utf-8"?>
 <p:sld xmlns:a="http://schemas.openxmlformats.org/drawingml/2006/main" xmlns:r="http://schemas.openxmlformats.org/officeDocument/2006/relationships" xmlns:p="http://schemas.openxmlformats.org/presentationml/2006/main">
   <p:cSld>
     <p:spTree>
@@ -10297,7 +10467,7 @@
 </p:sld>
 </file>
 
-<file path=ppt/slides/slide14.xml><?xml version="1.0" encoding="utf-8"?>
+<file path=ppt/slides/slide15.xml><?xml version="1.0" encoding="utf-8"?>
 <p:sld xmlns:a="http://schemas.openxmlformats.org/drawingml/2006/main" xmlns:r="http://schemas.openxmlformats.org/officeDocument/2006/relationships" xmlns:p="http://schemas.openxmlformats.org/presentationml/2006/main">
   <p:cSld>
     <p:spTree>
@@ -10518,7 +10688,7 @@
 </p:sld>
 </file>
 
-<file path=ppt/slides/slide15.xml><?xml version="1.0" encoding="utf-8"?>
+<file path=ppt/slides/slide16.xml><?xml version="1.0" encoding="utf-8"?>
 <p:sld xmlns:a="http://schemas.openxmlformats.org/drawingml/2006/main" xmlns:r="http://schemas.openxmlformats.org/officeDocument/2006/relationships" xmlns:p="http://schemas.openxmlformats.org/presentationml/2006/main">
   <p:cSld>
     <p:spTree>
@@ -10739,7 +10909,7 @@
 </p:sld>
 </file>
 
-<file path=ppt/slides/slide16.xml><?xml version="1.0" encoding="utf-8"?>
+<file path=ppt/slides/slide17.xml><?xml version="1.0" encoding="utf-8"?>
 <p:sld xmlns:a="http://schemas.openxmlformats.org/drawingml/2006/main" xmlns:r="http://schemas.openxmlformats.org/officeDocument/2006/relationships" xmlns:p="http://schemas.openxmlformats.org/presentationml/2006/main">
   <p:cSld>
     <p:spTree>
@@ -10960,7 +11130,7 @@
 </p:sld>
 </file>
 
-<file path=ppt/slides/slide17.xml><?xml version="1.0" encoding="utf-8"?>
+<file path=ppt/slides/slide18.xml><?xml version="1.0" encoding="utf-8"?>
 <p:sld xmlns:a="http://schemas.openxmlformats.org/drawingml/2006/main" xmlns:r="http://schemas.openxmlformats.org/officeDocument/2006/relationships" xmlns:p="http://schemas.openxmlformats.org/presentationml/2006/main">
   <p:cSld>
     <p:spTree>
@@ -11181,7 +11351,7 @@
 </p:sld>
 </file>
 
-<file path=ppt/slides/slide18.xml><?xml version="1.0" encoding="utf-8"?>
+<file path=ppt/slides/slide19.xml><?xml version="1.0" encoding="utf-8"?>
 <p:sld xmlns:a="http://schemas.openxmlformats.org/drawingml/2006/main" xmlns:r="http://schemas.openxmlformats.org/officeDocument/2006/relationships" xmlns:p="http://schemas.openxmlformats.org/presentationml/2006/main">
   <p:cSld>
     <p:spTree>
@@ -11397,7 +11567,259 @@
 </p:sld>
 </file>
 
-<file path=ppt/slides/slide19.xml><?xml version="1.0" encoding="utf-8"?>
+<file path=ppt/slides/slide2.xml><?xml version="1.0" encoding="utf-8"?>
+<p:sld xmlns:a="http://schemas.openxmlformats.org/drawingml/2006/main" xmlns:r="http://schemas.openxmlformats.org/officeDocument/2006/relationships" xmlns:p="http://schemas.openxmlformats.org/presentationml/2006/main">
+  <p:cSld>
+    <p:spTree>
+      <p:nvGrpSpPr>
+        <p:cNvPr id="1" name=""/>
+        <p:cNvGrpSpPr/>
+        <p:nvPr/>
+      </p:nvGrpSpPr>
+      <p:grpSpPr>
+        <a:xfrm>
+          <a:off x="0" y="0"/>
+          <a:ext cx="0" cy="0"/>
+          <a:chOff x="0" y="0"/>
+          <a:chExt cx="0" cy="0"/>
+        </a:xfrm>
+      </p:grpSpPr>
+      <p:sp>
+        <p:nvSpPr>
+          <p:cNvPr id="2" name="Título 1">
+            <a:extLst>
+              <a:ext uri="{FF2B5EF4-FFF2-40B4-BE49-F238E27FC236}">
+                <a16:creationId xmlns:a16="http://schemas.microsoft.com/office/drawing/2014/main" id="{51AC9907-8F59-4834-438F-D73319220179}"/>
+              </a:ext>
+            </a:extLst>
+          </p:cNvPr>
+          <p:cNvSpPr>
+            <a:spLocks noGrp="1"/>
+          </p:cNvSpPr>
+          <p:nvPr>
+            <p:ph type="title"/>
+          </p:nvPr>
+        </p:nvSpPr>
+        <p:spPr>
+          <a:xfrm>
+            <a:off x="1449217" y="804889"/>
+            <a:ext cx="9605635" cy="915053"/>
+          </a:xfrm>
+        </p:spPr>
+        <p:txBody>
+          <a:bodyPr/>
+          <a:lstStyle/>
+          <a:p>
+            <a:r>
+              <a:rPr lang="en-US" noProof="0" dirty="0"/>
+              <a:t>INTRODUCTION (BACKGROUND)</a:t>
+            </a:r>
+          </a:p>
+        </p:txBody>
+      </p:sp>
+      <p:sp>
+        <p:nvSpPr>
+          <p:cNvPr id="3" name="Marcador de contenido 2">
+            <a:extLst>
+              <a:ext uri="{FF2B5EF4-FFF2-40B4-BE49-F238E27FC236}">
+                <a16:creationId xmlns:a16="http://schemas.microsoft.com/office/drawing/2014/main" id="{42E259FA-7430-3761-944C-FDE77C596B6E}"/>
+              </a:ext>
+            </a:extLst>
+          </p:cNvPr>
+          <p:cNvSpPr>
+            <a:spLocks noGrp="1"/>
+          </p:cNvSpPr>
+          <p:nvPr>
+            <p:ph sz="half" idx="1"/>
+          </p:nvPr>
+        </p:nvSpPr>
+        <p:spPr>
+          <a:xfrm>
+            <a:off x="1164772" y="2010878"/>
+            <a:ext cx="5319597" cy="3943608"/>
+          </a:xfrm>
+        </p:spPr>
+        <p:txBody>
+          <a:bodyPr>
+            <a:noAutofit/>
+          </a:bodyPr>
+          <a:lstStyle/>
+          <a:p>
+            <a:r>
+              <a:rPr lang="en-US" sz="1800" noProof="0" dirty="0"/>
+              <a:t>Background:  </a:t>
+            </a:r>
+            <a:r>
+              <a:rPr lang="en-US" sz="1800" i="1" noProof="0" dirty="0" err="1"/>
+              <a:t>Philaenus</a:t>
+            </a:r>
+            <a:r>
+              <a:rPr lang="en-US" sz="1800" i="1" noProof="0" dirty="0"/>
+              <a:t> </a:t>
+            </a:r>
+            <a:r>
+              <a:rPr lang="en-US" sz="1800" i="1" noProof="0" dirty="0" err="1"/>
+              <a:t>spumarius</a:t>
+            </a:r>
+            <a:r>
+              <a:rPr lang="en-US" sz="1800" i="1" noProof="0" dirty="0"/>
+              <a:t> </a:t>
+            </a:r>
+            <a:r>
+              <a:rPr lang="en-US" sz="1800" noProof="0" dirty="0"/>
+              <a:t>(“meadow spittlebug”) is a major vector of </a:t>
+            </a:r>
+            <a:r>
+              <a:rPr lang="en-US" sz="1800" i="1" noProof="0" dirty="0"/>
+              <a:t>Xylella fastidiosa </a:t>
+            </a:r>
+            <a:r>
+              <a:rPr lang="en-US" sz="1800" noProof="0" dirty="0"/>
+              <a:t>(also known as Pierce’s disease), a devastating plant pathogen in Europe.</a:t>
+            </a:r>
+          </a:p>
+          <a:p>
+            <a:r>
+              <a:rPr lang="en-US" sz="1800" noProof="0" dirty="0"/>
+              <a:t>Effective control of </a:t>
+            </a:r>
+            <a:r>
+              <a:rPr lang="en-US" sz="1800" i="1" noProof="0" dirty="0"/>
+              <a:t>P. </a:t>
+            </a:r>
+            <a:r>
+              <a:rPr lang="en-US" sz="1800" i="1" noProof="0" dirty="0" err="1"/>
+              <a:t>spumarius</a:t>
+            </a:r>
+            <a:r>
+              <a:rPr lang="en-US" sz="1800" i="1" noProof="0" dirty="0"/>
+              <a:t> </a:t>
+            </a:r>
+            <a:r>
+              <a:rPr lang="en-US" sz="1800" noProof="0" dirty="0"/>
+              <a:t>is important for managing </a:t>
+            </a:r>
+            <a:r>
+              <a:rPr lang="en-US" sz="1800" i="1" noProof="0" dirty="0"/>
+              <a:t>Xylella</a:t>
+            </a:r>
+            <a:r>
+              <a:rPr lang="en-US" sz="1800" noProof="0" dirty="0"/>
+              <a:t> outbreaks and ensuring crop health.</a:t>
+            </a:r>
+          </a:p>
+          <a:p>
+            <a:r>
+              <a:rPr lang="en-US" sz="1800" noProof="0" dirty="0"/>
+              <a:t>Several insecticides, including ISOCLAST™ (sulfoxaflor), are available to control sap-feeding pests such as the aforementioned. There is a need to assess and compare their efficacy and persistence of these products under semi-field conditions.</a:t>
+            </a:r>
+          </a:p>
+        </p:txBody>
+      </p:sp>
+      <p:pic>
+        <p:nvPicPr>
+          <p:cNvPr id="7" name="Marcador de contenido 6">
+            <a:extLst>
+              <a:ext uri="{FF2B5EF4-FFF2-40B4-BE49-F238E27FC236}">
+                <a16:creationId xmlns:a16="http://schemas.microsoft.com/office/drawing/2014/main" id="{3C9F4586-8A6E-5DE7-2918-7B1A12BD0B3E}"/>
+              </a:ext>
+            </a:extLst>
+          </p:cNvPr>
+          <p:cNvPicPr>
+            <a:picLocks noGrp="1" noChangeAspect="1"/>
+          </p:cNvPicPr>
+          <p:nvPr>
+            <p:ph sz="half" idx="2"/>
+          </p:nvPr>
+        </p:nvPicPr>
+        <p:blipFill>
+          <a:blip r:embed="rId2">
+            <a:extLst>
+              <a:ext uri="{28A0092B-C50C-407E-A947-70E740481C1C}">
+                <a14:useLocalDpi xmlns:a14="http://schemas.microsoft.com/office/drawing/2010/main" val="0"/>
+              </a:ext>
+              <a:ext uri="{837473B0-CC2E-450A-ABE3-18F120FF3D39}">
+                <a1611:picAttrSrcUrl xmlns:a1611="http://schemas.microsoft.com/office/drawing/2016/11/main" r:id="rId3"/>
+              </a:ext>
+            </a:extLst>
+          </a:blip>
+          <a:stretch>
+            <a:fillRect/>
+          </a:stretch>
+        </p:blipFill>
+        <p:spPr>
+          <a:xfrm>
+            <a:off x="6691198" y="1925511"/>
+            <a:ext cx="4937125" cy="3211059"/>
+          </a:xfrm>
+        </p:spPr>
+      </p:pic>
+      <p:sp>
+        <p:nvSpPr>
+          <p:cNvPr id="8" name="CuadroTexto 7">
+            <a:extLst>
+              <a:ext uri="{FF2B5EF4-FFF2-40B4-BE49-F238E27FC236}">
+                <a16:creationId xmlns:a16="http://schemas.microsoft.com/office/drawing/2014/main" id="{32B07AB2-78A4-1EDB-CACF-B3181FE83FDA}"/>
+              </a:ext>
+            </a:extLst>
+          </p:cNvPr>
+          <p:cNvSpPr txBox="1"/>
+          <p:nvPr/>
+        </p:nvSpPr>
+        <p:spPr>
+          <a:xfrm>
+            <a:off x="6691198" y="5136570"/>
+            <a:ext cx="5054488" cy="646331"/>
+          </a:xfrm>
+          <a:prstGeom prst="rect">
+            <a:avLst/>
+          </a:prstGeom>
+          <a:noFill/>
+        </p:spPr>
+        <p:txBody>
+          <a:bodyPr wrap="square" rtlCol="0">
+            <a:spAutoFit/>
+          </a:bodyPr>
+          <a:lstStyle/>
+          <a:p>
+            <a:r>
+              <a:rPr lang="en-US" sz="1200" noProof="0" dirty="0"/>
+              <a:t>This photograph is from </a:t>
+            </a:r>
+            <a:r>
+              <a:rPr lang="en-US" sz="1200" noProof="0" dirty="0">
+                <a:hlinkClick r:id="rId4"/>
+              </a:rPr>
+              <a:t>https://www.marylandbiodiversity.com/species/11054</a:t>
+            </a:r>
+            <a:r>
+              <a:rPr lang="en-US" sz="1200" noProof="0" dirty="0"/>
+              <a:t> is under license </a:t>
+            </a:r>
+            <a:r>
+              <a:rPr lang="en-US" sz="1200" noProof="0" dirty="0">
+                <a:hlinkClick r:id="rId5" tooltip="https://creativecommons.org/licenses/by/3.0/"/>
+              </a:rPr>
+              <a:t>CC BY</a:t>
+            </a:r>
+            <a:endParaRPr lang="en-US" sz="1200" noProof="0" dirty="0"/>
+          </a:p>
+        </p:txBody>
+      </p:sp>
+    </p:spTree>
+    <p:extLst>
+      <p:ext uri="{BB962C8B-B14F-4D97-AF65-F5344CB8AC3E}">
+        <p14:creationId xmlns:p14="http://schemas.microsoft.com/office/powerpoint/2010/main" val="2541220704"/>
+      </p:ext>
+    </p:extLst>
+  </p:cSld>
+  <p:clrMapOvr>
+    <a:masterClrMapping/>
+  </p:clrMapOvr>
+</p:sld>
+</file>
+
+<file path=ppt/slides/slide20.xml><?xml version="1.0" encoding="utf-8"?>
 <p:sld xmlns:a="http://schemas.openxmlformats.org/drawingml/2006/main" xmlns:r="http://schemas.openxmlformats.org/officeDocument/2006/relationships" xmlns:p="http://schemas.openxmlformats.org/presentationml/2006/main">
   <p:cSld>
     <p:spTree>
@@ -11974,259 +12396,7 @@
 </p:sld>
 </file>
 
-<file path=ppt/slides/slide2.xml><?xml version="1.0" encoding="utf-8"?>
-<p:sld xmlns:a="http://schemas.openxmlformats.org/drawingml/2006/main" xmlns:r="http://schemas.openxmlformats.org/officeDocument/2006/relationships" xmlns:p="http://schemas.openxmlformats.org/presentationml/2006/main">
-  <p:cSld>
-    <p:spTree>
-      <p:nvGrpSpPr>
-        <p:cNvPr id="1" name=""/>
-        <p:cNvGrpSpPr/>
-        <p:nvPr/>
-      </p:nvGrpSpPr>
-      <p:grpSpPr>
-        <a:xfrm>
-          <a:off x="0" y="0"/>
-          <a:ext cx="0" cy="0"/>
-          <a:chOff x="0" y="0"/>
-          <a:chExt cx="0" cy="0"/>
-        </a:xfrm>
-      </p:grpSpPr>
-      <p:sp>
-        <p:nvSpPr>
-          <p:cNvPr id="2" name="Título 1">
-            <a:extLst>
-              <a:ext uri="{FF2B5EF4-FFF2-40B4-BE49-F238E27FC236}">
-                <a16:creationId xmlns:a16="http://schemas.microsoft.com/office/drawing/2014/main" id="{51AC9907-8F59-4834-438F-D73319220179}"/>
-              </a:ext>
-            </a:extLst>
-          </p:cNvPr>
-          <p:cNvSpPr>
-            <a:spLocks noGrp="1"/>
-          </p:cNvSpPr>
-          <p:nvPr>
-            <p:ph type="title"/>
-          </p:nvPr>
-        </p:nvSpPr>
-        <p:spPr>
-          <a:xfrm>
-            <a:off x="1449217" y="804889"/>
-            <a:ext cx="9605635" cy="915053"/>
-          </a:xfrm>
-        </p:spPr>
-        <p:txBody>
-          <a:bodyPr/>
-          <a:lstStyle/>
-          <a:p>
-            <a:r>
-              <a:rPr lang="en-US" noProof="0" dirty="0"/>
-              <a:t>INTRODUCTION (BACKGROUND)</a:t>
-            </a:r>
-          </a:p>
-        </p:txBody>
-      </p:sp>
-      <p:sp>
-        <p:nvSpPr>
-          <p:cNvPr id="3" name="Marcador de contenido 2">
-            <a:extLst>
-              <a:ext uri="{FF2B5EF4-FFF2-40B4-BE49-F238E27FC236}">
-                <a16:creationId xmlns:a16="http://schemas.microsoft.com/office/drawing/2014/main" id="{42E259FA-7430-3761-944C-FDE77C596B6E}"/>
-              </a:ext>
-            </a:extLst>
-          </p:cNvPr>
-          <p:cNvSpPr>
-            <a:spLocks noGrp="1"/>
-          </p:cNvSpPr>
-          <p:nvPr>
-            <p:ph sz="half" idx="1"/>
-          </p:nvPr>
-        </p:nvSpPr>
-        <p:spPr>
-          <a:xfrm>
-            <a:off x="1164772" y="2010878"/>
-            <a:ext cx="5319597" cy="3943608"/>
-          </a:xfrm>
-        </p:spPr>
-        <p:txBody>
-          <a:bodyPr>
-            <a:noAutofit/>
-          </a:bodyPr>
-          <a:lstStyle/>
-          <a:p>
-            <a:r>
-              <a:rPr lang="en-US" sz="1800" noProof="0" dirty="0"/>
-              <a:t>Background:  </a:t>
-            </a:r>
-            <a:r>
-              <a:rPr lang="en-US" sz="1800" i="1" noProof="0" dirty="0" err="1"/>
-              <a:t>Philaenus</a:t>
-            </a:r>
-            <a:r>
-              <a:rPr lang="en-US" sz="1800" i="1" noProof="0" dirty="0"/>
-              <a:t> </a:t>
-            </a:r>
-            <a:r>
-              <a:rPr lang="en-US" sz="1800" i="1" noProof="0" dirty="0" err="1"/>
-              <a:t>spumarius</a:t>
-            </a:r>
-            <a:r>
-              <a:rPr lang="en-US" sz="1800" i="1" noProof="0" dirty="0"/>
-              <a:t> </a:t>
-            </a:r>
-            <a:r>
-              <a:rPr lang="en-US" sz="1800" noProof="0" dirty="0"/>
-              <a:t>(“meadow spittlebug”) is a major vector of </a:t>
-            </a:r>
-            <a:r>
-              <a:rPr lang="en-US" sz="1800" i="1" noProof="0" dirty="0"/>
-              <a:t>Xylella fastidiosa </a:t>
-            </a:r>
-            <a:r>
-              <a:rPr lang="en-US" sz="1800" noProof="0" dirty="0"/>
-              <a:t>(also known as Pierce’s disease), a devastating plant pathogen in Europe.</a:t>
-            </a:r>
-          </a:p>
-          <a:p>
-            <a:r>
-              <a:rPr lang="en-US" sz="1800" noProof="0" dirty="0"/>
-              <a:t>Effective control of </a:t>
-            </a:r>
-            <a:r>
-              <a:rPr lang="en-US" sz="1800" i="1" noProof="0" dirty="0"/>
-              <a:t>P. </a:t>
-            </a:r>
-            <a:r>
-              <a:rPr lang="en-US" sz="1800" i="1" noProof="0" dirty="0" err="1"/>
-              <a:t>spumarius</a:t>
-            </a:r>
-            <a:r>
-              <a:rPr lang="en-US" sz="1800" i="1" noProof="0" dirty="0"/>
-              <a:t> </a:t>
-            </a:r>
-            <a:r>
-              <a:rPr lang="en-US" sz="1800" noProof="0" dirty="0"/>
-              <a:t>is important for managing </a:t>
-            </a:r>
-            <a:r>
-              <a:rPr lang="en-US" sz="1800" i="1" noProof="0" dirty="0"/>
-              <a:t>Xylella</a:t>
-            </a:r>
-            <a:r>
-              <a:rPr lang="en-US" sz="1800" noProof="0" dirty="0"/>
-              <a:t> outbreaks and ensuring crop health.</a:t>
-            </a:r>
-          </a:p>
-          <a:p>
-            <a:r>
-              <a:rPr lang="en-US" sz="1800" noProof="0" dirty="0"/>
-              <a:t>Several insecticides, including ISOCLAST™ (sulfoxaflor), are available to control sap-feeding pests such as the aforementioned. There is a need to assess and compare their efficacy and persistence of these products under semi-field conditions.</a:t>
-            </a:r>
-          </a:p>
-        </p:txBody>
-      </p:sp>
-      <p:pic>
-        <p:nvPicPr>
-          <p:cNvPr id="7" name="Marcador de contenido 6">
-            <a:extLst>
-              <a:ext uri="{FF2B5EF4-FFF2-40B4-BE49-F238E27FC236}">
-                <a16:creationId xmlns:a16="http://schemas.microsoft.com/office/drawing/2014/main" id="{3C9F4586-8A6E-5DE7-2918-7B1A12BD0B3E}"/>
-              </a:ext>
-            </a:extLst>
-          </p:cNvPr>
-          <p:cNvPicPr>
-            <a:picLocks noGrp="1" noChangeAspect="1"/>
-          </p:cNvPicPr>
-          <p:nvPr>
-            <p:ph sz="half" idx="2"/>
-          </p:nvPr>
-        </p:nvPicPr>
-        <p:blipFill>
-          <a:blip r:embed="rId2">
-            <a:extLst>
-              <a:ext uri="{28A0092B-C50C-407E-A947-70E740481C1C}">
-                <a14:useLocalDpi xmlns:a14="http://schemas.microsoft.com/office/drawing/2010/main" val="0"/>
-              </a:ext>
-              <a:ext uri="{837473B0-CC2E-450A-ABE3-18F120FF3D39}">
-                <a1611:picAttrSrcUrl xmlns:a1611="http://schemas.microsoft.com/office/drawing/2016/11/main" r:id="rId3"/>
-              </a:ext>
-            </a:extLst>
-          </a:blip>
-          <a:stretch>
-            <a:fillRect/>
-          </a:stretch>
-        </p:blipFill>
-        <p:spPr>
-          <a:xfrm>
-            <a:off x="6691198" y="1925511"/>
-            <a:ext cx="4937125" cy="3211059"/>
-          </a:xfrm>
-        </p:spPr>
-      </p:pic>
-      <p:sp>
-        <p:nvSpPr>
-          <p:cNvPr id="8" name="CuadroTexto 7">
-            <a:extLst>
-              <a:ext uri="{FF2B5EF4-FFF2-40B4-BE49-F238E27FC236}">
-                <a16:creationId xmlns:a16="http://schemas.microsoft.com/office/drawing/2014/main" id="{32B07AB2-78A4-1EDB-CACF-B3181FE83FDA}"/>
-              </a:ext>
-            </a:extLst>
-          </p:cNvPr>
-          <p:cNvSpPr txBox="1"/>
-          <p:nvPr/>
-        </p:nvSpPr>
-        <p:spPr>
-          <a:xfrm>
-            <a:off x="6691198" y="5136570"/>
-            <a:ext cx="5054488" cy="646331"/>
-          </a:xfrm>
-          <a:prstGeom prst="rect">
-            <a:avLst/>
-          </a:prstGeom>
-          <a:noFill/>
-        </p:spPr>
-        <p:txBody>
-          <a:bodyPr wrap="square" rtlCol="0">
-            <a:spAutoFit/>
-          </a:bodyPr>
-          <a:lstStyle/>
-          <a:p>
-            <a:r>
-              <a:rPr lang="en-US" sz="1200" noProof="0" dirty="0"/>
-              <a:t>This photograph is from </a:t>
-            </a:r>
-            <a:r>
-              <a:rPr lang="en-US" sz="1200" noProof="0" dirty="0">
-                <a:hlinkClick r:id="rId4"/>
-              </a:rPr>
-              <a:t>https://www.marylandbiodiversity.com/species/11054</a:t>
-            </a:r>
-            <a:r>
-              <a:rPr lang="en-US" sz="1200" noProof="0" dirty="0"/>
-              <a:t> is under license </a:t>
-            </a:r>
-            <a:r>
-              <a:rPr lang="en-US" sz="1200" noProof="0" dirty="0">
-                <a:hlinkClick r:id="rId5" tooltip="https://creativecommons.org/licenses/by/3.0/"/>
-              </a:rPr>
-              <a:t>CC BY</a:t>
-            </a:r>
-            <a:endParaRPr lang="en-US" sz="1200" noProof="0" dirty="0"/>
-          </a:p>
-        </p:txBody>
-      </p:sp>
-    </p:spTree>
-    <p:extLst>
-      <p:ext uri="{BB962C8B-B14F-4D97-AF65-F5344CB8AC3E}">
-        <p14:creationId xmlns:p14="http://schemas.microsoft.com/office/powerpoint/2010/main" val="2541220704"/>
-      </p:ext>
-    </p:extLst>
-  </p:cSld>
-  <p:clrMapOvr>
-    <a:masterClrMapping/>
-  </p:clrMapOvr>
-</p:sld>
-</file>
-
-<file path=ppt/slides/slide20.xml><?xml version="1.0" encoding="utf-8"?>
+<file path=ppt/slides/slide21.xml><?xml version="1.0" encoding="utf-8"?>
 <p:sld xmlns:a="http://schemas.openxmlformats.org/drawingml/2006/main" xmlns:r="http://schemas.openxmlformats.org/officeDocument/2006/relationships" xmlns:p="http://schemas.openxmlformats.org/presentationml/2006/main">
   <p:cSld>
     <p:spTree>
@@ -12831,7 +13001,7 @@
 </p:sld>
 </file>
 
-<file path=ppt/slides/slide21.xml><?xml version="1.0" encoding="utf-8"?>
+<file path=ppt/slides/slide22.xml><?xml version="1.0" encoding="utf-8"?>
 <p:sld xmlns:a="http://schemas.openxmlformats.org/drawingml/2006/main" xmlns:r="http://schemas.openxmlformats.org/officeDocument/2006/relationships" xmlns:p="http://schemas.openxmlformats.org/presentationml/2006/main">
   <p:cSld>
     <p:spTree>
@@ -13244,7 +13414,7 @@
 </p:sld>
 </file>
 
-<file path=ppt/slides/slide22.xml><?xml version="1.0" encoding="utf-8"?>
+<file path=ppt/slides/slide23.xml><?xml version="1.0" encoding="utf-8"?>
 <p:sld xmlns:a="http://schemas.openxmlformats.org/drawingml/2006/main" xmlns:r="http://schemas.openxmlformats.org/officeDocument/2006/relationships" xmlns:p="http://schemas.openxmlformats.org/presentationml/2006/main">
   <p:cSld>
     <p:spTree>
@@ -14623,7 +14793,7 @@
 </p:sld>
 </file>
 
-<file path=ppt/slides/slide23.xml><?xml version="1.0" encoding="utf-8"?>
+<file path=ppt/slides/slide24.xml><?xml version="1.0" encoding="utf-8"?>
 <p:sld xmlns:a="http://schemas.openxmlformats.org/drawingml/2006/main" xmlns:r="http://schemas.openxmlformats.org/officeDocument/2006/relationships" xmlns:p="http://schemas.openxmlformats.org/presentationml/2006/main">
   <p:cSld>
     <p:spTree>

</xml_diff>